<commit_message>
changed colors in pendulum.png
</commit_message>
<xml_diff>
--- a/content/07_num_ode/01_intro_RK/images/pendulum.pptx
+++ b/content/07_num_ode/01_intro_RK/images/pendulum.pptx
@@ -117,7 +117,7 @@
 <file path=ppt/revisionInfo.xml><?xml version="1.0" encoding="utf-8"?>
 <p1510:revInfo xmlns:a="http://schemas.openxmlformats.org/drawingml/2006/main" xmlns:r="http://schemas.openxmlformats.org/officeDocument/2006/relationships" xmlns:p1510="http://schemas.microsoft.com/office/powerpoint/2015/10/main">
   <p1510:revLst>
-    <p1510:client id="{E8E394EF-4048-48CC-9197-8D679777FC30}" v="52" dt="2022-03-17T11:14:19.215"/>
+    <p1510:client id="{84929B0C-37A2-423C-B030-BC1A645653C0}" v="2" dt="2022-03-23T13:47:28.556"/>
   </p1510:revLst>
 </p1510:revInfo>
 </file>
@@ -183,6 +183,262 @@
             <pc:docMk/>
             <pc:sldMk cId="485044438" sldId="257"/>
             <ac:cxnSpMk id="39" creationId="{FA1DCB33-368A-4A5A-B2F0-71AE4D15D18B}"/>
+          </ac:cxnSpMkLst>
+        </pc:cxnChg>
+      </pc:sldChg>
+    </pc:docChg>
+  </pc:docChgLst>
+  <pc:docChgLst>
+    <pc:chgData name="philipp.spelten@365h-brs.de" userId="bf49d2dc-2959-4525-96a1-3447e597065c" providerId="ADAL" clId="{84929B0C-37A2-423C-B030-BC1A645653C0}"/>
+    <pc:docChg chg="undo custSel modSld">
+      <pc:chgData name="philipp.spelten@365h-brs.de" userId="bf49d2dc-2959-4525-96a1-3447e597065c" providerId="ADAL" clId="{84929B0C-37A2-423C-B030-BC1A645653C0}" dt="2022-03-23T13:47:38.319" v="12" actId="208"/>
+      <pc:docMkLst>
+        <pc:docMk/>
+      </pc:docMkLst>
+      <pc:sldChg chg="modSp mod">
+        <pc:chgData name="philipp.spelten@365h-brs.de" userId="bf49d2dc-2959-4525-96a1-3447e597065c" providerId="ADAL" clId="{84929B0C-37A2-423C-B030-BC1A645653C0}" dt="2022-03-23T13:47:38.319" v="12" actId="208"/>
+        <pc:sldMkLst>
+          <pc:docMk/>
+          <pc:sldMk cId="3239150023" sldId="258"/>
+        </pc:sldMkLst>
+        <pc:spChg chg="mod">
+          <ac:chgData name="philipp.spelten@365h-brs.de" userId="bf49d2dc-2959-4525-96a1-3447e597065c" providerId="ADAL" clId="{84929B0C-37A2-423C-B030-BC1A645653C0}" dt="2022-03-23T13:40:19.547" v="1" actId="207"/>
+          <ac:spMkLst>
+            <pc:docMk/>
+            <pc:sldMk cId="3239150023" sldId="258"/>
+            <ac:spMk id="9" creationId="{06212ECA-3137-4FAB-AA98-F4AD3328C9E7}"/>
+          </ac:spMkLst>
+        </pc:spChg>
+        <pc:spChg chg="mod">
+          <ac:chgData name="philipp.spelten@365h-brs.de" userId="bf49d2dc-2959-4525-96a1-3447e597065c" providerId="ADAL" clId="{84929B0C-37A2-423C-B030-BC1A645653C0}" dt="2022-03-23T13:40:19.547" v="1" actId="207"/>
+          <ac:spMkLst>
+            <pc:docMk/>
+            <pc:sldMk cId="3239150023" sldId="258"/>
+            <ac:spMk id="15" creationId="{1952163C-95C4-4966-A7C8-A6758103642D}"/>
+          </ac:spMkLst>
+        </pc:spChg>
+        <pc:spChg chg="mod">
+          <ac:chgData name="philipp.spelten@365h-brs.de" userId="bf49d2dc-2959-4525-96a1-3447e597065c" providerId="ADAL" clId="{84929B0C-37A2-423C-B030-BC1A645653C0}" dt="2022-03-23T13:46:41.445" v="7" actId="207"/>
+          <ac:spMkLst>
+            <pc:docMk/>
+            <pc:sldMk cId="3239150023" sldId="258"/>
+            <ac:spMk id="19" creationId="{CC8F9226-CA2E-435B-A968-F5739E4ECE91}"/>
+          </ac:spMkLst>
+        </pc:spChg>
+        <pc:spChg chg="mod">
+          <ac:chgData name="philipp.spelten@365h-brs.de" userId="bf49d2dc-2959-4525-96a1-3447e597065c" providerId="ADAL" clId="{84929B0C-37A2-423C-B030-BC1A645653C0}" dt="2022-03-23T13:46:52.215" v="8" actId="2085"/>
+          <ac:spMkLst>
+            <pc:docMk/>
+            <pc:sldMk cId="3239150023" sldId="258"/>
+            <ac:spMk id="21" creationId="{B54D63E4-D0EA-4D8B-AA5E-5603B6E3E42E}"/>
+          </ac:spMkLst>
+        </pc:spChg>
+        <pc:spChg chg="mod">
+          <ac:chgData name="philipp.spelten@365h-brs.de" userId="bf49d2dc-2959-4525-96a1-3447e597065c" providerId="ADAL" clId="{84929B0C-37A2-423C-B030-BC1A645653C0}" dt="2022-03-23T13:46:52.215" v="8" actId="2085"/>
+          <ac:spMkLst>
+            <pc:docMk/>
+            <pc:sldMk cId="3239150023" sldId="258"/>
+            <ac:spMk id="23" creationId="{95D1FCCC-8D71-4979-9473-6014B2FDDECD}"/>
+          </ac:spMkLst>
+        </pc:spChg>
+        <pc:spChg chg="mod">
+          <ac:chgData name="philipp.spelten@365h-brs.de" userId="bf49d2dc-2959-4525-96a1-3447e597065c" providerId="ADAL" clId="{84929B0C-37A2-423C-B030-BC1A645653C0}" dt="2022-03-23T13:47:28.556" v="11" actId="207"/>
+          <ac:spMkLst>
+            <pc:docMk/>
+            <pc:sldMk cId="3239150023" sldId="258"/>
+            <ac:spMk id="25" creationId="{42AF8E02-9CA4-40AC-8119-22FA9F6D1223}"/>
+          </ac:spMkLst>
+        </pc:spChg>
+        <pc:spChg chg="mod">
+          <ac:chgData name="philipp.spelten@365h-brs.de" userId="bf49d2dc-2959-4525-96a1-3447e597065c" providerId="ADAL" clId="{84929B0C-37A2-423C-B030-BC1A645653C0}" dt="2022-03-23T13:47:28.556" v="11" actId="207"/>
+          <ac:spMkLst>
+            <pc:docMk/>
+            <pc:sldMk cId="3239150023" sldId="258"/>
+            <ac:spMk id="26" creationId="{0DC7C962-E691-4339-98C3-247F50FC9F43}"/>
+          </ac:spMkLst>
+        </pc:spChg>
+        <pc:spChg chg="mod">
+          <ac:chgData name="philipp.spelten@365h-brs.de" userId="bf49d2dc-2959-4525-96a1-3447e597065c" providerId="ADAL" clId="{84929B0C-37A2-423C-B030-BC1A645653C0}" dt="2022-03-23T13:46:52.215" v="8" actId="2085"/>
+          <ac:spMkLst>
+            <pc:docMk/>
+            <pc:sldMk cId="3239150023" sldId="258"/>
+            <ac:spMk id="31" creationId="{68AD63AF-7E2A-41C5-9796-048774A6BAD0}"/>
+          </ac:spMkLst>
+        </pc:spChg>
+        <pc:spChg chg="mod">
+          <ac:chgData name="philipp.spelten@365h-brs.de" userId="bf49d2dc-2959-4525-96a1-3447e597065c" providerId="ADAL" clId="{84929B0C-37A2-423C-B030-BC1A645653C0}" dt="2022-03-23T13:46:52.215" v="8" actId="2085"/>
+          <ac:spMkLst>
+            <pc:docMk/>
+            <pc:sldMk cId="3239150023" sldId="258"/>
+            <ac:spMk id="34" creationId="{7879B12F-DB81-4DC9-B424-CBF7A20D7909}"/>
+          </ac:spMkLst>
+        </pc:spChg>
+        <pc:spChg chg="mod">
+          <ac:chgData name="philipp.spelten@365h-brs.de" userId="bf49d2dc-2959-4525-96a1-3447e597065c" providerId="ADAL" clId="{84929B0C-37A2-423C-B030-BC1A645653C0}" dt="2022-03-23T13:46:41.445" v="7" actId="207"/>
+          <ac:spMkLst>
+            <pc:docMk/>
+            <pc:sldMk cId="3239150023" sldId="258"/>
+            <ac:spMk id="35" creationId="{7D0F6D72-1023-4EF1-850D-BEF49E0A4DD5}"/>
+          </ac:spMkLst>
+        </pc:spChg>
+        <pc:spChg chg="mod">
+          <ac:chgData name="philipp.spelten@365h-brs.de" userId="bf49d2dc-2959-4525-96a1-3447e597065c" providerId="ADAL" clId="{84929B0C-37A2-423C-B030-BC1A645653C0}" dt="2022-03-23T13:46:52.215" v="8" actId="2085"/>
+          <ac:spMkLst>
+            <pc:docMk/>
+            <pc:sldMk cId="3239150023" sldId="258"/>
+            <ac:spMk id="36" creationId="{FEEC2804-3101-48A4-B586-986878F53FC2}"/>
+          </ac:spMkLst>
+        </pc:spChg>
+        <pc:spChg chg="mod">
+          <ac:chgData name="philipp.spelten@365h-brs.de" userId="bf49d2dc-2959-4525-96a1-3447e597065c" providerId="ADAL" clId="{84929B0C-37A2-423C-B030-BC1A645653C0}" dt="2022-03-23T13:40:19.547" v="1" actId="207"/>
+          <ac:spMkLst>
+            <pc:docMk/>
+            <pc:sldMk cId="3239150023" sldId="258"/>
+            <ac:spMk id="43" creationId="{B280D380-E84A-4B01-8566-CA4435BDF3A7}"/>
+          </ac:spMkLst>
+        </pc:spChg>
+        <pc:spChg chg="mod">
+          <ac:chgData name="philipp.spelten@365h-brs.de" userId="bf49d2dc-2959-4525-96a1-3447e597065c" providerId="ADAL" clId="{84929B0C-37A2-423C-B030-BC1A645653C0}" dt="2022-03-23T13:40:45.321" v="3" actId="207"/>
+          <ac:spMkLst>
+            <pc:docMk/>
+            <pc:sldMk cId="3239150023" sldId="258"/>
+            <ac:spMk id="49" creationId="{2D61255A-8F01-4472-B551-F43BB814C545}"/>
+          </ac:spMkLst>
+        </pc:spChg>
+        <pc:spChg chg="mod">
+          <ac:chgData name="philipp.spelten@365h-brs.de" userId="bf49d2dc-2959-4525-96a1-3447e597065c" providerId="ADAL" clId="{84929B0C-37A2-423C-B030-BC1A645653C0}" dt="2022-03-23T13:47:16.551" v="10" actId="207"/>
+          <ac:spMkLst>
+            <pc:docMk/>
+            <pc:sldMk cId="3239150023" sldId="258"/>
+            <ac:spMk id="58" creationId="{0D5CCA2D-7192-4D03-893F-69C0D66AECD1}"/>
+          </ac:spMkLst>
+        </pc:spChg>
+        <pc:cxnChg chg="mod">
+          <ac:chgData name="philipp.spelten@365h-brs.de" userId="bf49d2dc-2959-4525-96a1-3447e597065c" providerId="ADAL" clId="{84929B0C-37A2-423C-B030-BC1A645653C0}" dt="2022-03-23T13:40:36.836" v="2" actId="208"/>
+          <ac:cxnSpMkLst>
+            <pc:docMk/>
+            <pc:sldMk cId="3239150023" sldId="258"/>
+            <ac:cxnSpMk id="6" creationId="{7B38E6A4-DE35-49CC-BCA5-4F3BAF3CB3EF}"/>
+          </ac:cxnSpMkLst>
+        </pc:cxnChg>
+        <pc:cxnChg chg="mod">
+          <ac:chgData name="philipp.spelten@365h-brs.de" userId="bf49d2dc-2959-4525-96a1-3447e597065c" providerId="ADAL" clId="{84929B0C-37A2-423C-B030-BC1A645653C0}" dt="2022-03-23T13:40:17.491" v="0" actId="208"/>
+          <ac:cxnSpMkLst>
+            <pc:docMk/>
+            <pc:sldMk cId="3239150023" sldId="258"/>
+            <ac:cxnSpMk id="8" creationId="{AB00BAD1-7D69-4E4B-9F8B-EF78B301382E}"/>
+          </ac:cxnSpMkLst>
+        </pc:cxnChg>
+        <pc:cxnChg chg="mod">
+          <ac:chgData name="philipp.spelten@365h-brs.de" userId="bf49d2dc-2959-4525-96a1-3447e597065c" providerId="ADAL" clId="{84929B0C-37A2-423C-B030-BC1A645653C0}" dt="2022-03-23T13:40:17.491" v="0" actId="208"/>
+          <ac:cxnSpMkLst>
+            <pc:docMk/>
+            <pc:sldMk cId="3239150023" sldId="258"/>
+            <ac:cxnSpMk id="10" creationId="{A2107F5D-CB78-4CDD-8FA8-C93D6698829E}"/>
+          </ac:cxnSpMkLst>
+        </pc:cxnChg>
+        <pc:cxnChg chg="mod">
+          <ac:chgData name="philipp.spelten@365h-brs.de" userId="bf49d2dc-2959-4525-96a1-3447e597065c" providerId="ADAL" clId="{84929B0C-37A2-423C-B030-BC1A645653C0}" dt="2022-03-23T13:40:17.491" v="0" actId="208"/>
+          <ac:cxnSpMkLst>
+            <pc:docMk/>
+            <pc:sldMk cId="3239150023" sldId="258"/>
+            <ac:cxnSpMk id="11" creationId="{72A987F8-09BD-43B0-8AE8-CE1AE2C2FAFE}"/>
+          </ac:cxnSpMkLst>
+        </pc:cxnChg>
+        <pc:cxnChg chg="mod">
+          <ac:chgData name="philipp.spelten@365h-brs.de" userId="bf49d2dc-2959-4525-96a1-3447e597065c" providerId="ADAL" clId="{84929B0C-37A2-423C-B030-BC1A645653C0}" dt="2022-03-23T13:40:17.491" v="0" actId="208"/>
+          <ac:cxnSpMkLst>
+            <pc:docMk/>
+            <pc:sldMk cId="3239150023" sldId="258"/>
+            <ac:cxnSpMk id="12" creationId="{67F9F334-09D7-4358-9D12-25A6B300C3EA}"/>
+          </ac:cxnSpMkLst>
+        </pc:cxnChg>
+        <pc:cxnChg chg="mod">
+          <ac:chgData name="philipp.spelten@365h-brs.de" userId="bf49d2dc-2959-4525-96a1-3447e597065c" providerId="ADAL" clId="{84929B0C-37A2-423C-B030-BC1A645653C0}" dt="2022-03-23T13:40:17.491" v="0" actId="208"/>
+          <ac:cxnSpMkLst>
+            <pc:docMk/>
+            <pc:sldMk cId="3239150023" sldId="258"/>
+            <ac:cxnSpMk id="13" creationId="{FF8B9CFA-E7AE-45B1-9560-49F87A682164}"/>
+          </ac:cxnSpMkLst>
+        </pc:cxnChg>
+        <pc:cxnChg chg="mod">
+          <ac:chgData name="philipp.spelten@365h-brs.de" userId="bf49d2dc-2959-4525-96a1-3447e597065c" providerId="ADAL" clId="{84929B0C-37A2-423C-B030-BC1A645653C0}" dt="2022-03-23T13:40:17.491" v="0" actId="208"/>
+          <ac:cxnSpMkLst>
+            <pc:docMk/>
+            <pc:sldMk cId="3239150023" sldId="258"/>
+            <ac:cxnSpMk id="14" creationId="{FC67219B-D025-4604-8968-428D83F57349}"/>
+          </ac:cxnSpMkLst>
+        </pc:cxnChg>
+        <pc:cxnChg chg="mod">
+          <ac:chgData name="philipp.spelten@365h-brs.de" userId="bf49d2dc-2959-4525-96a1-3447e597065c" providerId="ADAL" clId="{84929B0C-37A2-423C-B030-BC1A645653C0}" dt="2022-03-23T13:47:38.319" v="12" actId="208"/>
+          <ac:cxnSpMkLst>
+            <pc:docMk/>
+            <pc:sldMk cId="3239150023" sldId="258"/>
+            <ac:cxnSpMk id="17" creationId="{18E4CDA2-4631-4F39-AD05-E21131D6B997}"/>
+          </ac:cxnSpMkLst>
+        </pc:cxnChg>
+        <pc:cxnChg chg="mod">
+          <ac:chgData name="philipp.spelten@365h-brs.de" userId="bf49d2dc-2959-4525-96a1-3447e597065c" providerId="ADAL" clId="{84929B0C-37A2-423C-B030-BC1A645653C0}" dt="2022-03-23T13:46:41.445" v="7" actId="207"/>
+          <ac:cxnSpMkLst>
+            <pc:docMk/>
+            <pc:sldMk cId="3239150023" sldId="258"/>
+            <ac:cxnSpMk id="18" creationId="{555E3926-6A18-4460-8779-03DCF4190397}"/>
+          </ac:cxnSpMkLst>
+        </pc:cxnChg>
+        <pc:cxnChg chg="mod">
+          <ac:chgData name="philipp.spelten@365h-brs.de" userId="bf49d2dc-2959-4525-96a1-3447e597065c" providerId="ADAL" clId="{84929B0C-37A2-423C-B030-BC1A645653C0}" dt="2022-03-23T13:47:38.319" v="12" actId="208"/>
+          <ac:cxnSpMkLst>
+            <pc:docMk/>
+            <pc:sldMk cId="3239150023" sldId="258"/>
+            <ac:cxnSpMk id="20" creationId="{F9604A42-314A-4399-9248-3C2C9111EABA}"/>
+          </ac:cxnSpMkLst>
+        </pc:cxnChg>
+        <pc:cxnChg chg="mod">
+          <ac:chgData name="philipp.spelten@365h-brs.de" userId="bf49d2dc-2959-4525-96a1-3447e597065c" providerId="ADAL" clId="{84929B0C-37A2-423C-B030-BC1A645653C0}" dt="2022-03-23T13:46:41.445" v="7" actId="207"/>
+          <ac:cxnSpMkLst>
+            <pc:docMk/>
+            <pc:sldMk cId="3239150023" sldId="258"/>
+            <ac:cxnSpMk id="22" creationId="{7632CD49-B762-408C-B9AE-F0F75391C9A2}"/>
+          </ac:cxnSpMkLst>
+        </pc:cxnChg>
+        <pc:cxnChg chg="mod">
+          <ac:chgData name="philipp.spelten@365h-brs.de" userId="bf49d2dc-2959-4525-96a1-3447e597065c" providerId="ADAL" clId="{84929B0C-37A2-423C-B030-BC1A645653C0}" dt="2022-03-23T13:46:41.445" v="7" actId="207"/>
+          <ac:cxnSpMkLst>
+            <pc:docMk/>
+            <pc:sldMk cId="3239150023" sldId="258"/>
+            <ac:cxnSpMk id="27" creationId="{C6C06F55-CFA4-49DB-AD41-868428B747AD}"/>
+          </ac:cxnSpMkLst>
+        </pc:cxnChg>
+        <pc:cxnChg chg="mod">
+          <ac:chgData name="philipp.spelten@365h-brs.de" userId="bf49d2dc-2959-4525-96a1-3447e597065c" providerId="ADAL" clId="{84929B0C-37A2-423C-B030-BC1A645653C0}" dt="2022-03-23T13:46:41.445" v="7" actId="207"/>
+          <ac:cxnSpMkLst>
+            <pc:docMk/>
+            <pc:sldMk cId="3239150023" sldId="258"/>
+            <ac:cxnSpMk id="28" creationId="{3390B3C7-D662-4BBC-AFEB-349087BD975C}"/>
+          </ac:cxnSpMkLst>
+        </pc:cxnChg>
+        <pc:cxnChg chg="mod">
+          <ac:chgData name="philipp.spelten@365h-brs.de" userId="bf49d2dc-2959-4525-96a1-3447e597065c" providerId="ADAL" clId="{84929B0C-37A2-423C-B030-BC1A645653C0}" dt="2022-03-23T13:46:41.445" v="7" actId="207"/>
+          <ac:cxnSpMkLst>
+            <pc:docMk/>
+            <pc:sldMk cId="3239150023" sldId="258"/>
+            <ac:cxnSpMk id="29" creationId="{676E3266-EB7E-4966-80C4-F86EED739A07}"/>
+          </ac:cxnSpMkLst>
+        </pc:cxnChg>
+        <pc:cxnChg chg="mod">
+          <ac:chgData name="philipp.spelten@365h-brs.de" userId="bf49d2dc-2959-4525-96a1-3447e597065c" providerId="ADAL" clId="{84929B0C-37A2-423C-B030-BC1A645653C0}" dt="2022-03-23T13:46:41.445" v="7" actId="207"/>
+          <ac:cxnSpMkLst>
+            <pc:docMk/>
+            <pc:sldMk cId="3239150023" sldId="258"/>
+            <ac:cxnSpMk id="30" creationId="{F6D1FB57-FAFA-4A30-BE49-9FB3CE80E329}"/>
+          </ac:cxnSpMkLst>
+        </pc:cxnChg>
+        <pc:cxnChg chg="mod">
+          <ac:chgData name="philipp.spelten@365h-brs.de" userId="bf49d2dc-2959-4525-96a1-3447e597065c" providerId="ADAL" clId="{84929B0C-37A2-423C-B030-BC1A645653C0}" dt="2022-03-23T13:46:41.445" v="7" actId="207"/>
+          <ac:cxnSpMkLst>
+            <pc:docMk/>
+            <pc:sldMk cId="3239150023" sldId="258"/>
+            <ac:cxnSpMk id="33" creationId="{CCAEF78D-4543-4261-B25B-B10DEA1CA6EA}"/>
           </ac:cxnSpMkLst>
         </pc:cxnChg>
       </pc:sldChg>
@@ -705,7 +961,7 @@
           <a:p>
             <a:fld id="{DF0535AC-730B-40C3-8785-3088AB223334}" type="datetimeFigureOut">
               <a:rPr lang="de-DE" smtClean="0"/>
-              <a:t>17.03.2022</a:t>
+              <a:t>23.03.2022</a:t>
             </a:fld>
             <a:endParaRPr lang="de-DE"/>
           </a:p>
@@ -903,7 +1159,7 @@
           <a:p>
             <a:fld id="{DF0535AC-730B-40C3-8785-3088AB223334}" type="datetimeFigureOut">
               <a:rPr lang="de-DE" smtClean="0"/>
-              <a:t>17.03.2022</a:t>
+              <a:t>23.03.2022</a:t>
             </a:fld>
             <a:endParaRPr lang="de-DE"/>
           </a:p>
@@ -1111,7 +1367,7 @@
           <a:p>
             <a:fld id="{DF0535AC-730B-40C3-8785-3088AB223334}" type="datetimeFigureOut">
               <a:rPr lang="de-DE" smtClean="0"/>
-              <a:t>17.03.2022</a:t>
+              <a:t>23.03.2022</a:t>
             </a:fld>
             <a:endParaRPr lang="de-DE"/>
           </a:p>
@@ -1309,7 +1565,7 @@
           <a:p>
             <a:fld id="{DF0535AC-730B-40C3-8785-3088AB223334}" type="datetimeFigureOut">
               <a:rPr lang="de-DE" smtClean="0"/>
-              <a:t>17.03.2022</a:t>
+              <a:t>23.03.2022</a:t>
             </a:fld>
             <a:endParaRPr lang="de-DE"/>
           </a:p>
@@ -1584,7 +1840,7 @@
           <a:p>
             <a:fld id="{DF0535AC-730B-40C3-8785-3088AB223334}" type="datetimeFigureOut">
               <a:rPr lang="de-DE" smtClean="0"/>
-              <a:t>17.03.2022</a:t>
+              <a:t>23.03.2022</a:t>
             </a:fld>
             <a:endParaRPr lang="de-DE"/>
           </a:p>
@@ -1849,7 +2105,7 @@
           <a:p>
             <a:fld id="{DF0535AC-730B-40C3-8785-3088AB223334}" type="datetimeFigureOut">
               <a:rPr lang="de-DE" smtClean="0"/>
-              <a:t>17.03.2022</a:t>
+              <a:t>23.03.2022</a:t>
             </a:fld>
             <a:endParaRPr lang="de-DE"/>
           </a:p>
@@ -2261,7 +2517,7 @@
           <a:p>
             <a:fld id="{DF0535AC-730B-40C3-8785-3088AB223334}" type="datetimeFigureOut">
               <a:rPr lang="de-DE" smtClean="0"/>
-              <a:t>17.03.2022</a:t>
+              <a:t>23.03.2022</a:t>
             </a:fld>
             <a:endParaRPr lang="de-DE"/>
           </a:p>
@@ -2402,7 +2658,7 @@
           <a:p>
             <a:fld id="{DF0535AC-730B-40C3-8785-3088AB223334}" type="datetimeFigureOut">
               <a:rPr lang="de-DE" smtClean="0"/>
-              <a:t>17.03.2022</a:t>
+              <a:t>23.03.2022</a:t>
             </a:fld>
             <a:endParaRPr lang="de-DE"/>
           </a:p>
@@ -2515,7 +2771,7 @@
           <a:p>
             <a:fld id="{DF0535AC-730B-40C3-8785-3088AB223334}" type="datetimeFigureOut">
               <a:rPr lang="de-DE" smtClean="0"/>
-              <a:t>17.03.2022</a:t>
+              <a:t>23.03.2022</a:t>
             </a:fld>
             <a:endParaRPr lang="de-DE"/>
           </a:p>
@@ -2826,7 +3082,7 @@
           <a:p>
             <a:fld id="{DF0535AC-730B-40C3-8785-3088AB223334}" type="datetimeFigureOut">
               <a:rPr lang="de-DE" smtClean="0"/>
-              <a:t>17.03.2022</a:t>
+              <a:t>23.03.2022</a:t>
             </a:fld>
             <a:endParaRPr lang="de-DE"/>
           </a:p>
@@ -3114,7 +3370,7 @@
           <a:p>
             <a:fld id="{DF0535AC-730B-40C3-8785-3088AB223334}" type="datetimeFigureOut">
               <a:rPr lang="de-DE" smtClean="0"/>
-              <a:t>17.03.2022</a:t>
+              <a:t>23.03.2022</a:t>
             </a:fld>
             <a:endParaRPr lang="de-DE"/>
           </a:p>
@@ -3355,7 +3611,7 @@
           <a:p>
             <a:fld id="{DF0535AC-730B-40C3-8785-3088AB223334}" type="datetimeFigureOut">
               <a:rPr lang="de-DE" smtClean="0"/>
-              <a:t>17.03.2022</a:t>
+              <a:t>23.03.2022</a:t>
             </a:fld>
             <a:endParaRPr lang="de-DE"/>
           </a:p>
@@ -6188,8 +6444,8 @@
           </p:sp>
         </mc:Fallback>
       </mc:AlternateContent>
-      <mc:AlternateContent xmlns:mc="http://schemas.openxmlformats.org/markup-compatibility/2006">
-        <mc:Choice xmlns:a14="http://schemas.microsoft.com/office/drawing/2010/main" Requires="a14">
+      <mc:AlternateContent xmlns:mc="http://schemas.openxmlformats.org/markup-compatibility/2006" xmlns:a14="http://schemas.microsoft.com/office/drawing/2010/main">
+        <mc:Choice Requires="a14">
           <p:sp>
             <p:nvSpPr>
               <p:cNvPr id="62" name="Textfeld 61">
@@ -6280,7 +6536,7 @@
             </p:txBody>
           </p:sp>
         </mc:Choice>
-        <mc:Fallback>
+        <mc:Fallback xmlns="">
           <p:sp>
             <p:nvSpPr>
               <p:cNvPr id="62" name="Textfeld 61">
@@ -6507,8 +6763,8 @@
           </a:fontRef>
         </p:style>
       </p:cxnSp>
-      <mc:AlternateContent xmlns:mc="http://schemas.openxmlformats.org/markup-compatibility/2006">
-        <mc:Choice xmlns:a14="http://schemas.microsoft.com/office/drawing/2010/main" Requires="a14">
+      <mc:AlternateContent xmlns:mc="http://schemas.openxmlformats.org/markup-compatibility/2006" xmlns:a14="http://schemas.microsoft.com/office/drawing/2010/main">
+        <mc:Choice Requires="a14">
           <p:sp>
             <p:nvSpPr>
               <p:cNvPr id="23" name="Textfeld 22">
@@ -6671,7 +6927,7 @@
             </p:txBody>
           </p:sp>
         </mc:Choice>
-        <mc:Fallback>
+        <mc:Fallback xmlns="">
           <p:sp>
             <p:nvSpPr>
               <p:cNvPr id="23" name="Textfeld 22">
@@ -7325,8 +7581,8 @@
           </a:p>
         </p:txBody>
       </p:sp>
-      <mc:AlternateContent xmlns:mc="http://schemas.openxmlformats.org/markup-compatibility/2006">
-        <mc:Choice xmlns:a14="http://schemas.microsoft.com/office/drawing/2010/main" Requires="a14">
+      <mc:AlternateContent xmlns:mc="http://schemas.openxmlformats.org/markup-compatibility/2006" xmlns:a14="http://schemas.microsoft.com/office/drawing/2010/main">
+        <mc:Choice Requires="a14">
           <p:sp>
             <p:nvSpPr>
               <p:cNvPr id="40" name="Textfeld 39">
@@ -7383,7 +7639,7 @@
             </p:txBody>
           </p:sp>
         </mc:Choice>
-        <mc:Fallback>
+        <mc:Fallback xmlns="">
           <p:sp>
             <p:nvSpPr>
               <p:cNvPr id="40" name="Textfeld 39">
@@ -7483,7 +7739,7 @@
           </a:prstGeom>
           <a:ln w="19050">
             <a:solidFill>
-              <a:srgbClr val="00B050"/>
+              <a:srgbClr val="0072BD"/>
             </a:solidFill>
             <a:prstDash val="lgDash"/>
           </a:ln>
@@ -7524,14 +7780,14 @@
             <a:avLst/>
           </a:prstGeom>
           <a:solidFill>
-            <a:srgbClr val="4472C4">
-              <a:alpha val="50196"/>
+            <a:srgbClr val="000000">
+              <a:alpha val="40000"/>
             </a:srgbClr>
           </a:solidFill>
           <a:ln>
             <a:solidFill>
-              <a:srgbClr val="4472C4">
-                <a:alpha val="47843"/>
+              <a:srgbClr val="000000">
+                <a:alpha val="40000"/>
               </a:srgbClr>
             </a:solidFill>
           </a:ln>
@@ -7587,8 +7843,8 @@
           </a:prstGeom>
           <a:ln w="57150">
             <a:solidFill>
-              <a:srgbClr val="4472C4">
-                <a:alpha val="50196"/>
+              <a:srgbClr val="000000">
+                <a:alpha val="40000"/>
               </a:srgbClr>
             </a:solidFill>
           </a:ln>
@@ -7632,7 +7888,11 @@
           <a:prstGeom prst="line">
             <a:avLst/>
           </a:prstGeom>
-          <a:ln w="57150"/>
+          <a:ln w="57150">
+            <a:solidFill>
+              <a:schemeClr val="tx1"/>
+            </a:solidFill>
+          </a:ln>
         </p:spPr>
         <p:style>
           <a:lnRef idx="1">
@@ -7669,6 +7929,14 @@
           <a:prstGeom prst="triangle">
             <a:avLst/>
           </a:prstGeom>
+          <a:solidFill>
+            <a:schemeClr val="tx1"/>
+          </a:solidFill>
+          <a:ln>
+            <a:solidFill>
+              <a:schemeClr val="tx1"/>
+            </a:solidFill>
+          </a:ln>
         </p:spPr>
         <p:style>
           <a:lnRef idx="2">
@@ -7717,6 +7985,11 @@
           <a:prstGeom prst="line">
             <a:avLst/>
           </a:prstGeom>
+          <a:ln>
+            <a:solidFill>
+              <a:schemeClr val="tx1"/>
+            </a:solidFill>
+          </a:ln>
         </p:spPr>
         <p:style>
           <a:lnRef idx="1">
@@ -7755,6 +8028,11 @@
           <a:prstGeom prst="line">
             <a:avLst/>
           </a:prstGeom>
+          <a:ln>
+            <a:solidFill>
+              <a:schemeClr val="tx1"/>
+            </a:solidFill>
+          </a:ln>
         </p:spPr>
         <p:style>
           <a:lnRef idx="1">
@@ -7793,6 +8071,11 @@
           <a:prstGeom prst="line">
             <a:avLst/>
           </a:prstGeom>
+          <a:ln>
+            <a:solidFill>
+              <a:schemeClr val="tx1"/>
+            </a:solidFill>
+          </a:ln>
         </p:spPr>
         <p:style>
           <a:lnRef idx="1">
@@ -7831,6 +8114,11 @@
           <a:prstGeom prst="line">
             <a:avLst/>
           </a:prstGeom>
+          <a:ln>
+            <a:solidFill>
+              <a:schemeClr val="tx1"/>
+            </a:solidFill>
+          </a:ln>
         </p:spPr>
         <p:style>
           <a:lnRef idx="1">
@@ -7869,6 +8157,11 @@
           <a:prstGeom prst="line">
             <a:avLst/>
           </a:prstGeom>
+          <a:ln>
+            <a:solidFill>
+              <a:schemeClr val="tx1"/>
+            </a:solidFill>
+          </a:ln>
         </p:spPr>
         <p:style>
           <a:lnRef idx="1">
@@ -7906,9 +8199,13 @@
             <a:avLst/>
           </a:prstGeom>
           <a:solidFill>
-            <a:schemeClr val="bg1"/>
+            <a:schemeClr val="tx1"/>
           </a:solidFill>
-          <a:ln w="28575"/>
+          <a:ln w="28575">
+            <a:solidFill>
+              <a:schemeClr val="tx1"/>
+            </a:solidFill>
+          </a:ln>
         </p:spPr>
         <p:style>
           <a:lnRef idx="2">
@@ -8005,7 +8302,7 @@
           </a:prstGeom>
           <a:ln w="57150">
             <a:solidFill>
-              <a:srgbClr val="FF0000"/>
+              <a:srgbClr val="D95319"/>
             </a:solidFill>
             <a:tailEnd type="triangle"/>
           </a:ln>
@@ -8050,7 +8347,7 @@
           </a:prstGeom>
           <a:ln w="28575">
             <a:solidFill>
-              <a:srgbClr val="00B050"/>
+              <a:srgbClr val="0072BD"/>
             </a:solidFill>
             <a:headEnd type="none" w="med" len="med"/>
             <a:tailEnd type="arrow" w="med" len="med"/>
@@ -8075,7 +8372,11 @@
           <a:lstStyle/>
           <a:p>
             <a:pPr algn="ctr"/>
-            <a:endParaRPr lang="de-DE"/>
+            <a:endParaRPr lang="de-DE">
+              <a:solidFill>
+                <a:srgbClr val="4472C4"/>
+              </a:solidFill>
+            </a:endParaRPr>
           </a:p>
         </p:txBody>
       </p:sp>
@@ -8104,7 +8405,7 @@
           </a:prstGeom>
           <a:ln w="57150">
             <a:solidFill>
-              <a:srgbClr val="FF0000"/>
+              <a:srgbClr val="D95319"/>
             </a:solidFill>
             <a:tailEnd type="triangle"/>
           </a:ln>
@@ -8147,6 +8448,9 @@
                 <a:avLst/>
               </a:prstGeom>
               <a:noFill/>
+              <a:ln>
+                <a:noFill/>
+              </a:ln>
             </p:spPr>
             <p:txBody>
               <a:bodyPr wrap="square" rtlCol="0">
@@ -8164,7 +8468,7 @@
                       <m:r>
                         <a:rPr lang="de-DE" sz="2800" b="1" i="1" smtClean="0">
                           <a:solidFill>
-                            <a:srgbClr val="00B050"/>
+                            <a:srgbClr val="4472C4"/>
                           </a:solidFill>
                           <a:latin typeface="Cambria Math" panose="02040503050406030204" pitchFamily="18" charset="0"/>
                         </a:rPr>
@@ -8175,7 +8479,7 @@
                 </a14:m>
                 <a:endParaRPr lang="de-DE" sz="2800" b="1" dirty="0">
                   <a:solidFill>
-                    <a:srgbClr val="00B050"/>
+                    <a:srgbClr val="4472C4"/>
                   </a:solidFill>
                 </a:endParaRPr>
               </a:p>
@@ -8211,6 +8515,9 @@
                   <a:fillRect/>
                 </a:stretch>
               </a:blipFill>
+              <a:ln>
+                <a:noFill/>
+              </a:ln>
             </p:spPr>
             <p:txBody>
               <a:bodyPr/>
@@ -8251,7 +8558,7 @@
           </a:prstGeom>
           <a:ln w="28575">
             <a:solidFill>
-              <a:srgbClr val="00B050"/>
+              <a:srgbClr val="0072BD"/>
             </a:solidFill>
             <a:prstDash val="solid"/>
             <a:headEnd type="arrow" w="med" len="med"/>
@@ -8296,6 +8603,9 @@
                 <a:avLst/>
               </a:prstGeom>
               <a:noFill/>
+              <a:ln>
+                <a:noFill/>
+              </a:ln>
             </p:spPr>
             <p:txBody>
               <a:bodyPr wrap="square" rtlCol="0">
@@ -8313,7 +8623,7 @@
                       <m:r>
                         <a:rPr lang="de-DE" sz="2800" b="1" i="1" smtClean="0">
                           <a:solidFill>
-                            <a:srgbClr val="00B050"/>
+                            <a:srgbClr val="4472C4"/>
                           </a:solidFill>
                           <a:latin typeface="Cambria Math" panose="02040503050406030204" pitchFamily="18" charset="0"/>
                         </a:rPr>
@@ -8324,7 +8634,7 @@
                 </a14:m>
                 <a:endParaRPr lang="de-DE" sz="2800" b="1" dirty="0">
                   <a:solidFill>
-                    <a:srgbClr val="00B050"/>
+                    <a:srgbClr val="4472C4"/>
                   </a:solidFill>
                 </a:endParaRPr>
               </a:p>
@@ -8360,6 +8670,9 @@
                   <a:fillRect/>
                 </a:stretch>
               </a:blipFill>
+              <a:ln>
+                <a:noFill/>
+              </a:ln>
             </p:spPr>
             <p:txBody>
               <a:bodyPr/>
@@ -8376,8 +8689,8 @@
           </p:sp>
         </mc:Fallback>
       </mc:AlternateContent>
-      <mc:AlternateContent xmlns:mc="http://schemas.openxmlformats.org/markup-compatibility/2006">
-        <mc:Choice xmlns:a14="http://schemas.microsoft.com/office/drawing/2010/main" Requires="a14">
+      <mc:AlternateContent xmlns:mc="http://schemas.openxmlformats.org/markup-compatibility/2006" xmlns:a14="http://schemas.microsoft.com/office/drawing/2010/main">
+        <mc:Choice Requires="a14">
           <p:sp>
             <p:nvSpPr>
               <p:cNvPr id="24" name="Textfeld 23">
@@ -8437,7 +8750,7 @@
             </p:txBody>
           </p:sp>
         </mc:Choice>
-        <mc:Fallback>
+        <mc:Fallback xmlns="">
           <p:sp>
             <p:nvSpPr>
               <p:cNvPr id="24" name="Textfeld 23">
@@ -8525,7 +8838,7 @@
                       <m:r>
                         <a:rPr lang="de-DE" sz="3200" b="1" i="1" smtClean="0">
                           <a:solidFill>
-                            <a:srgbClr val="FF0000"/>
+                            <a:srgbClr val="D95319"/>
                           </a:solidFill>
                           <a:latin typeface="Cambria Math" panose="02040503050406030204" pitchFamily="18" charset="0"/>
                         </a:rPr>
@@ -8536,7 +8849,7 @@
                           <m:ctrlPr>
                             <a:rPr lang="de-DE" sz="3200" b="1" i="1" smtClean="0">
                               <a:solidFill>
-                                <a:srgbClr val="FF0000"/>
+                                <a:srgbClr val="D95319"/>
                               </a:solidFill>
                               <a:latin typeface="Cambria Math" panose="02040503050406030204" pitchFamily="18" charset="0"/>
                             </a:rPr>
@@ -8546,7 +8859,7 @@
                           <m:r>
                             <a:rPr lang="de-DE" sz="3200" b="1" i="1" smtClean="0">
                               <a:solidFill>
-                                <a:srgbClr val="FF0000"/>
+                                <a:srgbClr val="D95319"/>
                               </a:solidFill>
                               <a:latin typeface="Cambria Math" panose="02040503050406030204" pitchFamily="18" charset="0"/>
                             </a:rPr>
@@ -8557,7 +8870,7 @@
                           <m:r>
                             <a:rPr lang="de-DE" sz="3200" b="1" i="1" smtClean="0">
                               <a:solidFill>
-                                <a:srgbClr val="FF0000"/>
+                                <a:srgbClr val="D95319"/>
                               </a:solidFill>
                               <a:latin typeface="Cambria Math" panose="02040503050406030204" pitchFamily="18" charset="0"/>
                             </a:rPr>
@@ -8570,7 +8883,7 @@
                 </a14:m>
                 <a:endParaRPr lang="de-DE" sz="3200" b="1" dirty="0">
                   <a:solidFill>
-                    <a:srgbClr val="FF0000"/>
+                    <a:srgbClr val="D95319"/>
                   </a:solidFill>
                 </a:endParaRPr>
               </a:p>
@@ -8662,7 +8975,7 @@
                       <m:r>
                         <a:rPr lang="de-DE" sz="3200" b="1" i="1" smtClean="0">
                           <a:solidFill>
-                            <a:srgbClr val="FF0000"/>
+                            <a:srgbClr val="D95319"/>
                           </a:solidFill>
                           <a:latin typeface="Cambria Math" panose="02040503050406030204" pitchFamily="18" charset="0"/>
                         </a:rPr>
@@ -8673,7 +8986,7 @@
                           <m:ctrlPr>
                             <a:rPr lang="de-DE" sz="3200" b="1" i="1" smtClean="0">
                               <a:solidFill>
-                                <a:srgbClr val="FF0000"/>
+                                <a:srgbClr val="D95319"/>
                               </a:solidFill>
                               <a:latin typeface="Cambria Math" panose="02040503050406030204" pitchFamily="18" charset="0"/>
                             </a:rPr>
@@ -8683,7 +8996,7 @@
                           <m:r>
                             <a:rPr lang="de-DE" sz="3200" b="1" i="1" smtClean="0">
                               <a:solidFill>
-                                <a:srgbClr val="FF0000"/>
+                                <a:srgbClr val="D95319"/>
                               </a:solidFill>
                               <a:latin typeface="Cambria Math" panose="02040503050406030204" pitchFamily="18" charset="0"/>
                             </a:rPr>
@@ -8694,7 +9007,7 @@
                           <m:r>
                             <a:rPr lang="de-DE" sz="3200" b="1" i="1" smtClean="0">
                               <a:solidFill>
-                                <a:srgbClr val="FF0000"/>
+                                <a:srgbClr val="D95319"/>
                               </a:solidFill>
                               <a:latin typeface="Cambria Math" panose="02040503050406030204" pitchFamily="18" charset="0"/>
                             </a:rPr>
@@ -8707,7 +9020,7 @@
                 </a14:m>
                 <a:endParaRPr lang="de-DE" sz="3200" b="1" dirty="0">
                   <a:solidFill>
-                    <a:srgbClr val="FF0000"/>
+                    <a:srgbClr val="D95319"/>
                   </a:solidFill>
                 </a:endParaRPr>
               </a:p>
@@ -8784,7 +9097,7 @@
           </a:prstGeom>
           <a:ln w="19050">
             <a:solidFill>
-              <a:srgbClr val="00B050"/>
+              <a:srgbClr val="0072BD"/>
             </a:solidFill>
             <a:prstDash val="lgDash"/>
           </a:ln>
@@ -8828,7 +9141,7 @@
           </a:prstGeom>
           <a:ln w="19050">
             <a:solidFill>
-              <a:srgbClr val="00B050"/>
+              <a:srgbClr val="0072BD"/>
             </a:solidFill>
             <a:prstDash val="lgDash"/>
           </a:ln>
@@ -8872,7 +9185,7 @@
           </a:prstGeom>
           <a:ln w="19050">
             <a:solidFill>
-              <a:srgbClr val="00B050"/>
+              <a:srgbClr val="0072BD"/>
             </a:solidFill>
             <a:prstDash val="lgDash"/>
           </a:ln>
@@ -8916,7 +9229,7 @@
           </a:prstGeom>
           <a:ln w="28575">
             <a:solidFill>
-              <a:srgbClr val="00B050"/>
+              <a:srgbClr val="0072BD"/>
             </a:solidFill>
             <a:prstDash val="solid"/>
             <a:headEnd type="arrow" w="med" len="med"/>
@@ -8961,6 +9274,9 @@
                 <a:avLst/>
               </a:prstGeom>
               <a:noFill/>
+              <a:ln>
+                <a:noFill/>
+              </a:ln>
             </p:spPr>
             <p:txBody>
               <a:bodyPr wrap="square" rtlCol="0">
@@ -8978,7 +9294,7 @@
                       <m:r>
                         <a:rPr lang="de-DE" sz="2800" b="1" i="1" smtClean="0">
                           <a:solidFill>
-                            <a:srgbClr val="00B050"/>
+                            <a:srgbClr val="4472C4"/>
                           </a:solidFill>
                           <a:latin typeface="Cambria Math" panose="02040503050406030204" pitchFamily="18" charset="0"/>
                         </a:rPr>
@@ -8989,7 +9305,7 @@
                 </a14:m>
                 <a:endParaRPr lang="de-DE" sz="2800" b="1" dirty="0">
                   <a:solidFill>
-                    <a:srgbClr val="00B050"/>
+                    <a:srgbClr val="4472C4"/>
                   </a:solidFill>
                 </a:endParaRPr>
               </a:p>
@@ -9025,6 +9341,9 @@
                   <a:fillRect/>
                 </a:stretch>
               </a:blipFill>
+              <a:ln>
+                <a:noFill/>
+              </a:ln>
             </p:spPr>
             <p:txBody>
               <a:bodyPr/>
@@ -9065,7 +9384,7 @@
           </a:prstGeom>
           <a:ln w="28575">
             <a:solidFill>
-              <a:srgbClr val="00B050"/>
+              <a:srgbClr val="0072BD"/>
             </a:solidFill>
             <a:prstDash val="solid"/>
             <a:headEnd type="arrow" w="med" len="med"/>
@@ -9110,6 +9429,9 @@
                 <a:avLst/>
               </a:prstGeom>
               <a:noFill/>
+              <a:ln>
+                <a:noFill/>
+              </a:ln>
             </p:spPr>
             <p:txBody>
               <a:bodyPr wrap="square" rtlCol="0">
@@ -9127,7 +9449,7 @@
                       <m:r>
                         <a:rPr lang="de-DE" sz="2800" b="1" i="1" smtClean="0">
                           <a:solidFill>
-                            <a:srgbClr val="00B050"/>
+                            <a:srgbClr val="4472C4"/>
                           </a:solidFill>
                           <a:latin typeface="Cambria Math" panose="02040503050406030204" pitchFamily="18" charset="0"/>
                         </a:rPr>
@@ -9136,7 +9458,7 @@
                       <m:r>
                         <a:rPr lang="de-DE" sz="2800" b="1" i="1" smtClean="0">
                           <a:solidFill>
-                            <a:srgbClr val="00B050"/>
+                            <a:srgbClr val="4472C4"/>
                           </a:solidFill>
                           <a:latin typeface="Cambria Math" panose="02040503050406030204" pitchFamily="18" charset="0"/>
                         </a:rPr>
@@ -9145,7 +9467,7 @@
                       <m:r>
                         <a:rPr lang="de-DE" sz="2800" b="1" i="1" smtClean="0">
                           <a:solidFill>
-                            <a:srgbClr val="00B050"/>
+                            <a:srgbClr val="4472C4"/>
                           </a:solidFill>
                           <a:latin typeface="Cambria Math" panose="02040503050406030204" pitchFamily="18" charset="0"/>
                         </a:rPr>
@@ -9156,7 +9478,7 @@
                           <m:ctrlPr>
                             <a:rPr lang="de-DE" sz="2800" b="1" i="1" smtClean="0">
                               <a:solidFill>
-                                <a:srgbClr val="00B050"/>
+                                <a:srgbClr val="4472C4"/>
                               </a:solidFill>
                               <a:latin typeface="Cambria Math" panose="02040503050406030204" pitchFamily="18" charset="0"/>
                             </a:rPr>
@@ -9166,7 +9488,7 @@
                           <m:r>
                             <a:rPr lang="de-DE" sz="2800" b="1" i="1" smtClean="0">
                               <a:solidFill>
-                                <a:srgbClr val="00B050"/>
+                                <a:srgbClr val="4472C4"/>
                               </a:solidFill>
                               <a:latin typeface="Cambria Math" panose="02040503050406030204" pitchFamily="18" charset="0"/>
                             </a:rPr>
@@ -9179,7 +9501,7 @@
                 </a14:m>
                 <a:endParaRPr lang="de-DE" sz="2800" b="1" dirty="0">
                   <a:solidFill>
-                    <a:srgbClr val="00B050"/>
+                    <a:srgbClr val="4472C4"/>
                   </a:solidFill>
                 </a:endParaRPr>
               </a:p>
@@ -9215,6 +9537,9 @@
                   <a:fillRect/>
                 </a:stretch>
               </a:blipFill>
+              <a:ln>
+                <a:noFill/>
+              </a:ln>
             </p:spPr>
             <p:txBody>
               <a:bodyPr/>
@@ -9256,7 +9581,7 @@
           </a:prstGeom>
           <a:ln w="28575">
             <a:solidFill>
-              <a:srgbClr val="00B050"/>
+              <a:srgbClr val="0072BD"/>
             </a:solidFill>
             <a:headEnd type="none" w="med" len="med"/>
             <a:tailEnd type="arrow" w="med" len="med"/>
@@ -9281,7 +9606,11 @@
           <a:lstStyle/>
           <a:p>
             <a:pPr algn="ctr"/>
-            <a:endParaRPr lang="de-DE"/>
+            <a:endParaRPr lang="de-DE">
+              <a:solidFill>
+                <a:srgbClr val="4472C4"/>
+              </a:solidFill>
+            </a:endParaRPr>
           </a:p>
         </p:txBody>
       </p:sp>
@@ -9308,6 +9637,9 @@
                 <a:avLst/>
               </a:prstGeom>
               <a:noFill/>
+              <a:ln>
+                <a:noFill/>
+              </a:ln>
             </p:spPr>
             <p:txBody>
               <a:bodyPr wrap="square" rtlCol="0">
@@ -9325,7 +9657,7 @@
                       <m:r>
                         <a:rPr lang="de-DE" sz="2800" b="1" i="1" smtClean="0">
                           <a:solidFill>
-                            <a:srgbClr val="00B050"/>
+                            <a:srgbClr val="4472C4"/>
                           </a:solidFill>
                           <a:latin typeface="Cambria Math" panose="02040503050406030204" pitchFamily="18" charset="0"/>
                         </a:rPr>
@@ -9336,7 +9668,7 @@
                 </a14:m>
                 <a:endParaRPr lang="de-DE" sz="2800" b="1" dirty="0">
                   <a:solidFill>
-                    <a:srgbClr val="00B050"/>
+                    <a:srgbClr val="4472C4"/>
                   </a:solidFill>
                 </a:endParaRPr>
               </a:p>
@@ -9372,6 +9704,9 @@
                   <a:fillRect/>
                 </a:stretch>
               </a:blipFill>
+              <a:ln>
+                <a:noFill/>
+              </a:ln>
             </p:spPr>
             <p:txBody>
               <a:bodyPr/>
@@ -9408,6 +9743,14 @@
           <a:prstGeom prst="ellipse">
             <a:avLst/>
           </a:prstGeom>
+          <a:solidFill>
+            <a:schemeClr val="tx1"/>
+          </a:solidFill>
+          <a:ln>
+            <a:solidFill>
+              <a:schemeClr val="tx1"/>
+            </a:solidFill>
+          </a:ln>
         </p:spPr>
         <p:style>
           <a:lnRef idx="2">
@@ -9466,7 +9809,7 @@
             <a:r>
               <a:rPr lang="de-DE" sz="2000" b="1" dirty="0">
                 <a:solidFill>
-                  <a:srgbClr val="FF0000"/>
+                  <a:srgbClr val="D95319"/>
                 </a:solidFill>
               </a:rPr>
               <a:t>Trägheits-/D‘Alembert-Kräfte</a:t>
@@ -9488,7 +9831,7 @@
             <a:r>
               <a:rPr lang="de-DE" sz="2000" b="1" dirty="0">
                 <a:solidFill>
-                  <a:srgbClr val="00B050"/>
+                  <a:srgbClr val="4472C4"/>
                 </a:solidFill>
               </a:rPr>
               <a:t>Maße</a:t>

</xml_diff>